<commit_message>
Update Nextflow and MultiQC logos
</commit_message>
<xml_diff>
--- a/docs/images/checkatlas_workflow.pptx
+++ b/docs/images/checkatlas_workflow.pptx
@@ -259,7 +259,7 @@
           <a:p>
             <a:fld id="{F69B9EA1-A223-A349-A164-DA0282C40E98}" type="datetimeFigureOut">
               <a:rPr lang="fr-FR" smtClean="0"/>
-              <a:t>24/07/2023</a:t>
+              <a:t>11/05/2026</a:t>
             </a:fld>
             <a:endParaRPr lang="fr-FR"/>
           </a:p>
@@ -313,7 +313,7 @@
           <a:p>
             <a:fld id="{510E6383-C17E-B040-B4E5-8E12DA4DE049}" type="slidenum">
               <a:rPr lang="fr-FR" smtClean="0"/>
-              <a:t>‹N°›</a:t>
+              <a:t>‹#›</a:t>
             </a:fld>
             <a:endParaRPr lang="fr-FR"/>
           </a:p>
@@ -457,7 +457,7 @@
           <a:p>
             <a:fld id="{F69B9EA1-A223-A349-A164-DA0282C40E98}" type="datetimeFigureOut">
               <a:rPr lang="fr-FR" smtClean="0"/>
-              <a:t>24/07/2023</a:t>
+              <a:t>11/05/2026</a:t>
             </a:fld>
             <a:endParaRPr lang="fr-FR"/>
           </a:p>
@@ -511,7 +511,7 @@
           <a:p>
             <a:fld id="{510E6383-C17E-B040-B4E5-8E12DA4DE049}" type="slidenum">
               <a:rPr lang="fr-FR" smtClean="0"/>
-              <a:t>‹N°›</a:t>
+              <a:t>‹#›</a:t>
             </a:fld>
             <a:endParaRPr lang="fr-FR"/>
           </a:p>
@@ -665,7 +665,7 @@
           <a:p>
             <a:fld id="{F69B9EA1-A223-A349-A164-DA0282C40E98}" type="datetimeFigureOut">
               <a:rPr lang="fr-FR" smtClean="0"/>
-              <a:t>24/07/2023</a:t>
+              <a:t>11/05/2026</a:t>
             </a:fld>
             <a:endParaRPr lang="fr-FR"/>
           </a:p>
@@ -719,7 +719,7 @@
           <a:p>
             <a:fld id="{510E6383-C17E-B040-B4E5-8E12DA4DE049}" type="slidenum">
               <a:rPr lang="fr-FR" smtClean="0"/>
-              <a:t>‹N°›</a:t>
+              <a:t>‹#›</a:t>
             </a:fld>
             <a:endParaRPr lang="fr-FR"/>
           </a:p>
@@ -863,7 +863,7 @@
           <a:p>
             <a:fld id="{F69B9EA1-A223-A349-A164-DA0282C40E98}" type="datetimeFigureOut">
               <a:rPr lang="fr-FR" smtClean="0"/>
-              <a:t>24/07/2023</a:t>
+              <a:t>11/05/2026</a:t>
             </a:fld>
             <a:endParaRPr lang="fr-FR"/>
           </a:p>
@@ -917,7 +917,7 @@
           <a:p>
             <a:fld id="{510E6383-C17E-B040-B4E5-8E12DA4DE049}" type="slidenum">
               <a:rPr lang="fr-FR" smtClean="0"/>
-              <a:t>‹N°›</a:t>
+              <a:t>‹#›</a:t>
             </a:fld>
             <a:endParaRPr lang="fr-FR"/>
           </a:p>
@@ -1138,7 +1138,7 @@
           <a:p>
             <a:fld id="{F69B9EA1-A223-A349-A164-DA0282C40E98}" type="datetimeFigureOut">
               <a:rPr lang="fr-FR" smtClean="0"/>
-              <a:t>24/07/2023</a:t>
+              <a:t>11/05/2026</a:t>
             </a:fld>
             <a:endParaRPr lang="fr-FR"/>
           </a:p>
@@ -1192,7 +1192,7 @@
           <a:p>
             <a:fld id="{510E6383-C17E-B040-B4E5-8E12DA4DE049}" type="slidenum">
               <a:rPr lang="fr-FR" smtClean="0"/>
-              <a:t>‹N°›</a:t>
+              <a:t>‹#›</a:t>
             </a:fld>
             <a:endParaRPr lang="fr-FR"/>
           </a:p>
@@ -1403,7 +1403,7 @@
           <a:p>
             <a:fld id="{F69B9EA1-A223-A349-A164-DA0282C40E98}" type="datetimeFigureOut">
               <a:rPr lang="fr-FR" smtClean="0"/>
-              <a:t>24/07/2023</a:t>
+              <a:t>11/05/2026</a:t>
             </a:fld>
             <a:endParaRPr lang="fr-FR"/>
           </a:p>
@@ -1457,7 +1457,7 @@
           <a:p>
             <a:fld id="{510E6383-C17E-B040-B4E5-8E12DA4DE049}" type="slidenum">
               <a:rPr lang="fr-FR" smtClean="0"/>
-              <a:t>‹N°›</a:t>
+              <a:t>‹#›</a:t>
             </a:fld>
             <a:endParaRPr lang="fr-FR"/>
           </a:p>
@@ -1815,7 +1815,7 @@
           <a:p>
             <a:fld id="{F69B9EA1-A223-A349-A164-DA0282C40E98}" type="datetimeFigureOut">
               <a:rPr lang="fr-FR" smtClean="0"/>
-              <a:t>24/07/2023</a:t>
+              <a:t>11/05/2026</a:t>
             </a:fld>
             <a:endParaRPr lang="fr-FR"/>
           </a:p>
@@ -1869,7 +1869,7 @@
           <a:p>
             <a:fld id="{510E6383-C17E-B040-B4E5-8E12DA4DE049}" type="slidenum">
               <a:rPr lang="fr-FR" smtClean="0"/>
-              <a:t>‹N°›</a:t>
+              <a:t>‹#›</a:t>
             </a:fld>
             <a:endParaRPr lang="fr-FR"/>
           </a:p>
@@ -1956,7 +1956,7 @@
           <a:p>
             <a:fld id="{F69B9EA1-A223-A349-A164-DA0282C40E98}" type="datetimeFigureOut">
               <a:rPr lang="fr-FR" smtClean="0"/>
-              <a:t>24/07/2023</a:t>
+              <a:t>11/05/2026</a:t>
             </a:fld>
             <a:endParaRPr lang="fr-FR"/>
           </a:p>
@@ -2010,7 +2010,7 @@
           <a:p>
             <a:fld id="{510E6383-C17E-B040-B4E5-8E12DA4DE049}" type="slidenum">
               <a:rPr lang="fr-FR" smtClean="0"/>
-              <a:t>‹N°›</a:t>
+              <a:t>‹#›</a:t>
             </a:fld>
             <a:endParaRPr lang="fr-FR"/>
           </a:p>
@@ -2069,7 +2069,7 @@
           <a:p>
             <a:fld id="{F69B9EA1-A223-A349-A164-DA0282C40E98}" type="datetimeFigureOut">
               <a:rPr lang="fr-FR" smtClean="0"/>
-              <a:t>24/07/2023</a:t>
+              <a:t>11/05/2026</a:t>
             </a:fld>
             <a:endParaRPr lang="fr-FR"/>
           </a:p>
@@ -2123,7 +2123,7 @@
           <a:p>
             <a:fld id="{510E6383-C17E-B040-B4E5-8E12DA4DE049}" type="slidenum">
               <a:rPr lang="fr-FR" smtClean="0"/>
-              <a:t>‹N°›</a:t>
+              <a:t>‹#›</a:t>
             </a:fld>
             <a:endParaRPr lang="fr-FR"/>
           </a:p>
@@ -2380,7 +2380,7 @@
           <a:p>
             <a:fld id="{F69B9EA1-A223-A349-A164-DA0282C40E98}" type="datetimeFigureOut">
               <a:rPr lang="fr-FR" smtClean="0"/>
-              <a:t>24/07/2023</a:t>
+              <a:t>11/05/2026</a:t>
             </a:fld>
             <a:endParaRPr lang="fr-FR"/>
           </a:p>
@@ -2434,7 +2434,7 @@
           <a:p>
             <a:fld id="{510E6383-C17E-B040-B4E5-8E12DA4DE049}" type="slidenum">
               <a:rPr lang="fr-FR" smtClean="0"/>
-              <a:t>‹N°›</a:t>
+              <a:t>‹#›</a:t>
             </a:fld>
             <a:endParaRPr lang="fr-FR"/>
           </a:p>
@@ -2668,7 +2668,7 @@
           <a:p>
             <a:fld id="{F69B9EA1-A223-A349-A164-DA0282C40E98}" type="datetimeFigureOut">
               <a:rPr lang="fr-FR" smtClean="0"/>
-              <a:t>24/07/2023</a:t>
+              <a:t>11/05/2026</a:t>
             </a:fld>
             <a:endParaRPr lang="fr-FR"/>
           </a:p>
@@ -2722,7 +2722,7 @@
           <a:p>
             <a:fld id="{510E6383-C17E-B040-B4E5-8E12DA4DE049}" type="slidenum">
               <a:rPr lang="fr-FR" smtClean="0"/>
-              <a:t>‹N°›</a:t>
+              <a:t>‹#›</a:t>
             </a:fld>
             <a:endParaRPr lang="fr-FR"/>
           </a:p>
@@ -2909,7 +2909,7 @@
           <a:p>
             <a:fld id="{F69B9EA1-A223-A349-A164-DA0282C40E98}" type="datetimeFigureOut">
               <a:rPr lang="fr-FR" smtClean="0"/>
-              <a:t>24/07/2023</a:t>
+              <a:t>11/05/2026</a:t>
             </a:fld>
             <a:endParaRPr lang="fr-FR"/>
           </a:p>
@@ -2999,7 +2999,7 @@
           <a:p>
             <a:fld id="{510E6383-C17E-B040-B4E5-8E12DA4DE049}" type="slidenum">
               <a:rPr lang="fr-FR" smtClean="0"/>
-              <a:t>‹N°›</a:t>
+              <a:t>‹#›</a:t>
             </a:fld>
             <a:endParaRPr lang="fr-FR"/>
           </a:p>
@@ -5368,66 +5368,6 @@
           </a:p>
         </p:txBody>
       </p:sp>
-      <p:pic>
-        <p:nvPicPr>
-          <p:cNvPr id="1027" name="Picture 3">
-            <a:extLst>
-              <a:ext uri="{FF2B5EF4-FFF2-40B4-BE49-F238E27FC236}">
-                <a16:creationId xmlns:a16="http://schemas.microsoft.com/office/drawing/2014/main" id="{816B4D42-5929-F6A3-9A04-5B10280D7DD7}"/>
-              </a:ext>
-            </a:extLst>
-          </p:cNvPr>
-          <p:cNvPicPr>
-            <a:picLocks noChangeAspect="1" noChangeArrowheads="1"/>
-          </p:cNvPicPr>
-          <p:nvPr/>
-        </p:nvPicPr>
-        <p:blipFill>
-          <a:blip r:embed="rId2">
-            <a:extLst>
-              <a:ext uri="{28A0092B-C50C-407E-A947-70E740481C1C}">
-                <a14:useLocalDpi xmlns:a14="http://schemas.microsoft.com/office/drawing/2010/main" val="0"/>
-              </a:ext>
-            </a:extLst>
-          </a:blip>
-          <a:srcRect/>
-          <a:stretch>
-            <a:fillRect/>
-          </a:stretch>
-        </p:blipFill>
-        <p:spPr bwMode="auto">
-          <a:xfrm>
-            <a:off x="3799975" y="5590512"/>
-            <a:ext cx="1421425" cy="510612"/>
-          </a:xfrm>
-          <a:prstGeom prst="rect">
-            <a:avLst/>
-          </a:prstGeom>
-          <a:noFill/>
-          <a:ln>
-            <a:noFill/>
-          </a:ln>
-          <a:extLst>
-            <a:ext uri="{909E8E84-426E-40DD-AFC4-6F175D3DCCD1}">
-              <a14:hiddenFill xmlns:a14="http://schemas.microsoft.com/office/drawing/2010/main">
-                <a:solidFill>
-                  <a:srgbClr val="FFFFFF"/>
-                </a:solidFill>
-              </a14:hiddenFill>
-            </a:ext>
-            <a:ext uri="{91240B29-F687-4F45-9708-019B960494DF}">
-              <a14:hiddenLine xmlns:a14="http://schemas.microsoft.com/office/drawing/2010/main" w="12700">
-                <a:solidFill>
-                  <a:srgbClr val="000000"/>
-                </a:solidFill>
-                <a:miter lim="400000"/>
-                <a:headEnd/>
-                <a:tailEnd/>
-              </a14:hiddenLine>
-            </a:ext>
-          </a:extLst>
-        </p:spPr>
-      </p:pic>
       <p:sp>
         <p:nvSpPr>
           <p:cNvPr id="21" name="Text Box 1" descr="One single html report">
@@ -5565,10 +5505,10 @@
       </p:cxnSp>
       <p:pic>
         <p:nvPicPr>
-          <p:cNvPr id="3" name="Image 2">
-            <a:extLst>
-              <a:ext uri="{FF2B5EF4-FFF2-40B4-BE49-F238E27FC236}">
-                <a16:creationId xmlns:a16="http://schemas.microsoft.com/office/drawing/2014/main" id="{6565D91F-718C-B4D8-6D72-89B9F888BE00}"/>
+          <p:cNvPr id="4" name="Image 3">
+            <a:extLst>
+              <a:ext uri="{FF2B5EF4-FFF2-40B4-BE49-F238E27FC236}">
+                <a16:creationId xmlns:a16="http://schemas.microsoft.com/office/drawing/2014/main" id="{FBBADD9B-1BB5-DE72-8131-A7CB27BEA457}"/>
               </a:ext>
             </a:extLst>
           </p:cNvPr>
@@ -5578,37 +5518,7 @@
           <p:nvPr/>
         </p:nvPicPr>
         <p:blipFill>
-          <a:blip r:embed="rId3"/>
-          <a:stretch>
-            <a:fillRect/>
-          </a:stretch>
-        </p:blipFill>
-        <p:spPr>
-          <a:xfrm>
-            <a:off x="666148" y="1617578"/>
-            <a:ext cx="1649462" cy="331593"/>
-          </a:xfrm>
-          <a:prstGeom prst="rect">
-            <a:avLst/>
-          </a:prstGeom>
-        </p:spPr>
-      </p:pic>
-      <p:pic>
-        <p:nvPicPr>
-          <p:cNvPr id="4" name="Image 3">
-            <a:extLst>
-              <a:ext uri="{FF2B5EF4-FFF2-40B4-BE49-F238E27FC236}">
-                <a16:creationId xmlns:a16="http://schemas.microsoft.com/office/drawing/2014/main" id="{FBBADD9B-1BB5-DE72-8131-A7CB27BEA457}"/>
-              </a:ext>
-            </a:extLst>
-          </p:cNvPr>
-          <p:cNvPicPr>
-            <a:picLocks noChangeAspect="1"/>
-          </p:cNvPicPr>
-          <p:nvPr/>
-        </p:nvPicPr>
-        <p:blipFill>
-          <a:blip r:embed="rId4"/>
+          <a:blip r:embed="rId2"/>
           <a:stretch>
             <a:fillRect/>
           </a:stretch>
@@ -5638,7 +5548,7 @@
           <p:nvPr/>
         </p:nvPicPr>
         <p:blipFill>
-          <a:blip r:embed="rId5"/>
+          <a:blip r:embed="rId3"/>
           <a:stretch>
             <a:fillRect/>
           </a:stretch>
@@ -5668,7 +5578,7 @@
           <p:nvPr/>
         </p:nvPicPr>
         <p:blipFill>
-          <a:blip r:embed="rId6"/>
+          <a:blip r:embed="rId4"/>
           <a:stretch>
             <a:fillRect/>
           </a:stretch>
@@ -5683,6 +5593,124 @@
           </a:prstGeom>
         </p:spPr>
       </p:pic>
+      <p:pic>
+        <p:nvPicPr>
+          <p:cNvPr id="24" name="Picture 23">
+            <a:extLst>
+              <a:ext uri="{FF2B5EF4-FFF2-40B4-BE49-F238E27FC236}">
+                <a16:creationId xmlns:a16="http://schemas.microsoft.com/office/drawing/2014/main" id="{3BB8CD07-A5D2-31DB-1AC5-66DB78141FA6}"/>
+              </a:ext>
+            </a:extLst>
+          </p:cNvPr>
+          <p:cNvPicPr>
+            <a:picLocks noChangeAspect="1"/>
+          </p:cNvPicPr>
+          <p:nvPr/>
+        </p:nvPicPr>
+        <p:blipFill>
+          <a:blip r:embed="rId5"/>
+          <a:stretch>
+            <a:fillRect/>
+          </a:stretch>
+        </p:blipFill>
+        <p:spPr>
+          <a:xfrm>
+            <a:off x="677139" y="1586590"/>
+            <a:ext cx="2031908" cy="331577"/>
+          </a:xfrm>
+          <a:prstGeom prst="rect">
+            <a:avLst/>
+          </a:prstGeom>
+        </p:spPr>
+      </p:pic>
+      <p:pic>
+        <p:nvPicPr>
+          <p:cNvPr id="27" name="Picture 26">
+            <a:extLst>
+              <a:ext uri="{FF2B5EF4-FFF2-40B4-BE49-F238E27FC236}">
+                <a16:creationId xmlns:a16="http://schemas.microsoft.com/office/drawing/2014/main" id="{2FAE7AED-E37F-C003-7F82-EDF783796843}"/>
+              </a:ext>
+            </a:extLst>
+          </p:cNvPr>
+          <p:cNvPicPr>
+            <a:picLocks noChangeAspect="1"/>
+          </p:cNvPicPr>
+          <p:nvPr/>
+        </p:nvPicPr>
+        <p:blipFill>
+          <a:blip r:embed="rId6"/>
+          <a:stretch>
+            <a:fillRect/>
+          </a:stretch>
+        </p:blipFill>
+        <p:spPr>
+          <a:xfrm>
+            <a:off x="3560641" y="5575364"/>
+            <a:ext cx="1643858" cy="311809"/>
+          </a:xfrm>
+          <a:prstGeom prst="rect">
+            <a:avLst/>
+          </a:prstGeom>
+        </p:spPr>
+      </p:pic>
+      <p:sp>
+        <p:nvSpPr>
+          <p:cNvPr id="29" name="TextBox 28">
+            <a:extLst>
+              <a:ext uri="{FF2B5EF4-FFF2-40B4-BE49-F238E27FC236}">
+                <a16:creationId xmlns:a16="http://schemas.microsoft.com/office/drawing/2014/main" id="{04A22873-E43D-0CA7-FE43-E9EC2D017ABB}"/>
+              </a:ext>
+            </a:extLst>
+          </p:cNvPr>
+          <p:cNvSpPr txBox="1"/>
+          <p:nvPr/>
+        </p:nvSpPr>
+        <p:spPr>
+          <a:xfrm>
+            <a:off x="3491857" y="5941823"/>
+            <a:ext cx="1758904" cy="261610"/>
+          </a:xfrm>
+          <a:prstGeom prst="rect">
+            <a:avLst/>
+          </a:prstGeom>
+          <a:noFill/>
+        </p:spPr>
+        <p:txBody>
+          <a:bodyPr wrap="square">
+            <a:spAutoFit/>
+          </a:bodyPr>
+          <a:lstStyle/>
+          <a:p>
+            <a:pPr marR="0" lvl="0" algn="l" defTabSz="914400" rtl="0" eaLnBrk="0" fontAlgn="base" latinLnBrk="0" hangingPunct="0">
+              <a:lnSpc>
+                <a:spcPct val="100000"/>
+              </a:lnSpc>
+              <a:spcBef>
+                <a:spcPct val="0"/>
+              </a:spcBef>
+              <a:spcAft>
+                <a:spcPct val="0"/>
+              </a:spcAft>
+              <a:buClrTx/>
+              <a:buSzTx/>
+              <a:tabLst/>
+            </a:pPr>
+            <a:r>
+              <a:rPr kumimoji="0" lang="fr-FR" altLang="fr-FR" sz="1100" b="0" i="0" u="none" strike="noStrike" cap="none" normalizeH="0" baseline="0" dirty="0">
+                <a:ln>
+                  <a:noFill/>
+                </a:ln>
+                <a:solidFill>
+                  <a:schemeClr val="tx1"/>
+                </a:solidFill>
+                <a:effectLst/>
+                <a:latin typeface="Helvetica" pitchFamily="2" charset="0"/>
+              </a:rPr>
+              <a:t>Check Single-Cell Atlas</a:t>
+            </a:r>
+          </a:p>
+        </p:txBody>
+      </p:sp>
     </p:spTree>
     <p:extLst>
       <p:ext uri="{BB962C8B-B14F-4D97-AF65-F5344CB8AC3E}">

</xml_diff>